<commit_message>
Add files via upload
</commit_message>
<xml_diff>
--- a/專題報告.pptx
+++ b/專題報告.pptx
@@ -15774,7 +15774,7 @@
             <a:tbl>
               <a:tblPr bandRow="1" firstRow="1">
                 <a:noFill/>
-                <a:tableStyleId>{EF69E1A0-1D1E-4D1B-942E-DECBBA917D81}</a:tableStyleId>
+                <a:tableStyleId>{5E8EC5A9-6023-4487-97EB-CF3F751AF50B}</a:tableStyleId>
               </a:tblPr>
               <a:tblGrid>
                 <a:gridCol w="3560375"/>
@@ -17031,7 +17031,7 @@
             <a:tbl>
               <a:tblPr bandRow="1" firstRow="1">
                 <a:noFill/>
-                <a:tableStyleId>{C5DC600F-0F91-4E06-A19A-CB638F39DDCE}</a:tableStyleId>
+                <a:tableStyleId>{D2D53864-C1FC-41F1-9294-DA812D1AD0D8}</a:tableStyleId>
               </a:tblPr>
               <a:tblGrid>
                 <a:gridCol w="3120250"/>
@@ -18280,7 +18280,7 @@
           <p:nvPr/>
         </p:nvGraphicFramePr>
         <p:xfrm>
-          <a:off x="700088" y="2292350"/>
+          <a:off x="700613" y="3016288"/>
           <a:ext cx="3000000" cy="3000000"/>
         </p:xfrm>
         <a:graphic>
@@ -18288,7 +18288,7 @@
             <a:tbl>
               <a:tblPr bandRow="1" firstRow="1">
                 <a:noFill/>
-                <a:tableStyleId>{C5DC600F-0F91-4E06-A19A-CB638F39DDCE}</a:tableStyleId>
+                <a:tableStyleId>{D2D53864-C1FC-41F1-9294-DA812D1AD0D8}</a:tableStyleId>
               </a:tblPr>
               <a:tblGrid>
                 <a:gridCol w="2791800"/>
@@ -18464,7 +18464,7 @@
                   </a:tcPr>
                 </a:tc>
               </a:tr>
-              <a:tr h="643750">
+              <a:tr h="919650">
                 <a:tc>
                   <a:txBody>
                     <a:bodyPr/>
@@ -18497,7 +18497,7 @@
                           <a:cs typeface="PMingLiU"/>
                           <a:sym typeface="PMingLiU"/>
                         </a:rPr>
-                        <a:t>ACC</a:t>
+                        <a:t>AUC</a:t>
                       </a:r>
                       <a:endParaRPr b="0" i="0" sz="2400">
                         <a:solidFill>
@@ -18581,7 +18581,7 @@
                           <a:cs typeface="PMingLiU"/>
                           <a:sym typeface="PMingLiU"/>
                         </a:rPr>
-                        <a:t>81.97%</a:t>
+                        <a:t>91.16%</a:t>
                       </a:r>
                       <a:endParaRPr b="0" i="0" sz="2400">
                         <a:solidFill>
@@ -18614,176 +18614,6 @@
                       <a:tailEnd len="sm" w="sm" type="none"/>
                     </a:lnR>
                     <a:lnT cap="flat" cmpd="sng" w="27600">
-                      <a:solidFill>
-                        <a:srgbClr val="FFFFFF"/>
-                      </a:solidFill>
-                      <a:prstDash val="solid"/>
-                      <a:round/>
-                      <a:headEnd len="sm" w="sm" type="none"/>
-                      <a:tailEnd len="sm" w="sm" type="none"/>
-                    </a:lnT>
-                    <a:lnB cap="flat" cmpd="sng" w="9525">
-                      <a:solidFill>
-                        <a:srgbClr val="FFFFFF"/>
-                      </a:solidFill>
-                      <a:prstDash val="solid"/>
-                      <a:round/>
-                      <a:headEnd len="sm" w="sm" type="none"/>
-                      <a:tailEnd len="sm" w="sm" type="none"/>
-                    </a:lnB>
-                  </a:tcPr>
-                </a:tc>
-              </a:tr>
-              <a:tr h="919650">
-                <a:tc>
-                  <a:txBody>
-                    <a:bodyPr/>
-                    <a:lstStyle/>
-                    <a:p>
-                      <a:pPr indent="0" lvl="0" marL="0" marR="0" rtl="0" algn="ctr">
-                        <a:lnSpc>
-                          <a:spcPct val="65625"/>
-                        </a:lnSpc>
-                        <a:spcBef>
-                          <a:spcPts val="0"/>
-                        </a:spcBef>
-                        <a:spcAft>
-                          <a:spcPts val="0"/>
-                        </a:spcAft>
-                        <a:buClr>
-                          <a:srgbClr val="000000"/>
-                        </a:buClr>
-                        <a:buSzPts val="2400"/>
-                        <a:buFont typeface="PMingLiU"/>
-                        <a:buNone/>
-                      </a:pPr>
-                      <a:r>
-                        <a:rPr b="0" i="0" lang="en-US" sz="2400" u="none" strike="noStrike">
-                          <a:solidFill>
-                            <a:srgbClr val="000000"/>
-                          </a:solidFill>
-                          <a:latin typeface="PMingLiU"/>
-                          <a:ea typeface="PMingLiU"/>
-                          <a:cs typeface="PMingLiU"/>
-                          <a:sym typeface="PMingLiU"/>
-                        </a:rPr>
-                        <a:t>AUC</a:t>
-                      </a:r>
-                      <a:endParaRPr b="0" i="0" sz="2400">
-                        <a:solidFill>
-                          <a:srgbClr val="000000"/>
-                        </a:solidFill>
-                        <a:latin typeface="PMingLiU"/>
-                        <a:ea typeface="PMingLiU"/>
-                        <a:cs typeface="PMingLiU"/>
-                        <a:sym typeface="PMingLiU"/>
-                      </a:endParaRPr>
-                    </a:p>
-                  </a:txBody>
-                  <a:tcPr marT="33150" marB="33150" marR="66300" marL="66300" anchor="ctr">
-                    <a:lnL cap="flat" cmpd="sng" w="9525">
-                      <a:solidFill>
-                        <a:srgbClr val="FFFFFF"/>
-                      </a:solidFill>
-                      <a:prstDash val="solid"/>
-                      <a:round/>
-                      <a:headEnd len="sm" w="sm" type="none"/>
-                      <a:tailEnd len="sm" w="sm" type="none"/>
-                    </a:lnL>
-                    <a:lnR cap="flat" cmpd="sng" w="9525">
-                      <a:solidFill>
-                        <a:srgbClr val="FFFFFF"/>
-                      </a:solidFill>
-                      <a:prstDash val="solid"/>
-                      <a:round/>
-                      <a:headEnd len="sm" w="sm" type="none"/>
-                      <a:tailEnd len="sm" w="sm" type="none"/>
-                    </a:lnR>
-                    <a:lnT cap="flat" cmpd="sng" w="9525">
-                      <a:solidFill>
-                        <a:srgbClr val="FFFFFF"/>
-                      </a:solidFill>
-                      <a:prstDash val="solid"/>
-                      <a:round/>
-                      <a:headEnd len="sm" w="sm" type="none"/>
-                      <a:tailEnd len="sm" w="sm" type="none"/>
-                    </a:lnT>
-                    <a:lnB cap="flat" cmpd="sng" w="9525">
-                      <a:solidFill>
-                        <a:srgbClr val="FFFFFF"/>
-                      </a:solidFill>
-                      <a:prstDash val="solid"/>
-                      <a:round/>
-                      <a:headEnd len="sm" w="sm" type="none"/>
-                      <a:tailEnd len="sm" w="sm" type="none"/>
-                    </a:lnB>
-                  </a:tcPr>
-                </a:tc>
-                <a:tc>
-                  <a:txBody>
-                    <a:bodyPr/>
-                    <a:lstStyle/>
-                    <a:p>
-                      <a:pPr indent="0" lvl="0" marL="0" marR="0" rtl="0" algn="ctr">
-                        <a:lnSpc>
-                          <a:spcPct val="65625"/>
-                        </a:lnSpc>
-                        <a:spcBef>
-                          <a:spcPts val="0"/>
-                        </a:spcBef>
-                        <a:spcAft>
-                          <a:spcPts val="0"/>
-                        </a:spcAft>
-                        <a:buClr>
-                          <a:srgbClr val="000000"/>
-                        </a:buClr>
-                        <a:buSzPts val="2400"/>
-                        <a:buFont typeface="PMingLiU"/>
-                        <a:buNone/>
-                      </a:pPr>
-                      <a:r>
-                        <a:rPr b="0" i="0" lang="en-US" sz="2400" u="none" strike="noStrike">
-                          <a:solidFill>
-                            <a:srgbClr val="000000"/>
-                          </a:solidFill>
-                          <a:latin typeface="PMingLiU"/>
-                          <a:ea typeface="PMingLiU"/>
-                          <a:cs typeface="PMingLiU"/>
-                          <a:sym typeface="PMingLiU"/>
-                        </a:rPr>
-                        <a:t>91.16%</a:t>
-                      </a:r>
-                      <a:endParaRPr b="0" i="0" sz="2400">
-                        <a:solidFill>
-                          <a:srgbClr val="000000"/>
-                        </a:solidFill>
-                        <a:latin typeface="PMingLiU"/>
-                        <a:ea typeface="PMingLiU"/>
-                        <a:cs typeface="PMingLiU"/>
-                        <a:sym typeface="PMingLiU"/>
-                      </a:endParaRPr>
-                    </a:p>
-                  </a:txBody>
-                  <a:tcPr marT="33150" marB="33150" marR="66300" marL="66300" anchor="ctr">
-                    <a:lnL cap="flat" cmpd="sng" w="9525">
-                      <a:solidFill>
-                        <a:srgbClr val="FFFFFF"/>
-                      </a:solidFill>
-                      <a:prstDash val="solid"/>
-                      <a:round/>
-                      <a:headEnd len="sm" w="sm" type="none"/>
-                      <a:tailEnd len="sm" w="sm" type="none"/>
-                    </a:lnL>
-                    <a:lnR cap="flat" cmpd="sng" w="9525">
-                      <a:solidFill>
-                        <a:srgbClr val="FFFFFF"/>
-                      </a:solidFill>
-                      <a:prstDash val="solid"/>
-                      <a:round/>
-                      <a:headEnd len="sm" w="sm" type="none"/>
-                      <a:tailEnd len="sm" w="sm" type="none"/>
-                    </a:lnR>
-                    <a:lnT cap="flat" cmpd="sng" w="9525">
                       <a:solidFill>
                         <a:srgbClr val="FFFFFF"/>
                       </a:solidFill>
@@ -18974,176 +18804,6 @@
                   </a:tcPr>
                 </a:tc>
               </a:tr>
-              <a:tr h="802650">
-                <a:tc>
-                  <a:txBody>
-                    <a:bodyPr/>
-                    <a:lstStyle/>
-                    <a:p>
-                      <a:pPr indent="0" lvl="0" marL="0" marR="0" rtl="0" algn="ctr">
-                        <a:lnSpc>
-                          <a:spcPct val="65625"/>
-                        </a:lnSpc>
-                        <a:spcBef>
-                          <a:spcPts val="0"/>
-                        </a:spcBef>
-                        <a:spcAft>
-                          <a:spcPts val="0"/>
-                        </a:spcAft>
-                        <a:buClr>
-                          <a:srgbClr val="000000"/>
-                        </a:buClr>
-                        <a:buSzPts val="2400"/>
-                        <a:buFont typeface="PMingLiU"/>
-                        <a:buNone/>
-                      </a:pPr>
-                      <a:r>
-                        <a:rPr b="0" i="0" lang="en-US" sz="2400" u="none" strike="noStrike">
-                          <a:solidFill>
-                            <a:srgbClr val="000000"/>
-                          </a:solidFill>
-                          <a:latin typeface="PMingLiU"/>
-                          <a:ea typeface="PMingLiU"/>
-                          <a:cs typeface="PMingLiU"/>
-                          <a:sym typeface="PMingLiU"/>
-                        </a:rPr>
-                        <a:t>AR</a:t>
-                      </a:r>
-                      <a:endParaRPr b="0" i="0" sz="2400">
-                        <a:solidFill>
-                          <a:srgbClr val="000000"/>
-                        </a:solidFill>
-                        <a:latin typeface="PMingLiU"/>
-                        <a:ea typeface="PMingLiU"/>
-                        <a:cs typeface="PMingLiU"/>
-                        <a:sym typeface="PMingLiU"/>
-                      </a:endParaRPr>
-                    </a:p>
-                  </a:txBody>
-                  <a:tcPr marT="33150" marB="33150" marR="66300" marL="66300" anchor="ctr">
-                    <a:lnL cap="flat" cmpd="sng" w="9525">
-                      <a:solidFill>
-                        <a:srgbClr val="FFFFFF"/>
-                      </a:solidFill>
-                      <a:prstDash val="solid"/>
-                      <a:round/>
-                      <a:headEnd len="sm" w="sm" type="none"/>
-                      <a:tailEnd len="sm" w="sm" type="none"/>
-                    </a:lnL>
-                    <a:lnR cap="flat" cmpd="sng" w="9525">
-                      <a:solidFill>
-                        <a:srgbClr val="FFFFFF"/>
-                      </a:solidFill>
-                      <a:prstDash val="solid"/>
-                      <a:round/>
-                      <a:headEnd len="sm" w="sm" type="none"/>
-                      <a:tailEnd len="sm" w="sm" type="none"/>
-                    </a:lnR>
-                    <a:lnT cap="flat" cmpd="sng" w="9525">
-                      <a:solidFill>
-                        <a:srgbClr val="FFFFFF"/>
-                      </a:solidFill>
-                      <a:prstDash val="solid"/>
-                      <a:round/>
-                      <a:headEnd len="sm" w="sm" type="none"/>
-                      <a:tailEnd len="sm" w="sm" type="none"/>
-                    </a:lnT>
-                    <a:lnB cap="flat" cmpd="sng" w="9525">
-                      <a:solidFill>
-                        <a:srgbClr val="FFFFFF"/>
-                      </a:solidFill>
-                      <a:prstDash val="solid"/>
-                      <a:round/>
-                      <a:headEnd len="sm" w="sm" type="none"/>
-                      <a:tailEnd len="sm" w="sm" type="none"/>
-                    </a:lnB>
-                  </a:tcPr>
-                </a:tc>
-                <a:tc>
-                  <a:txBody>
-                    <a:bodyPr/>
-                    <a:lstStyle/>
-                    <a:p>
-                      <a:pPr indent="0" lvl="0" marL="0" marR="0" rtl="0" algn="ctr">
-                        <a:lnSpc>
-                          <a:spcPct val="65625"/>
-                        </a:lnSpc>
-                        <a:spcBef>
-                          <a:spcPts val="0"/>
-                        </a:spcBef>
-                        <a:spcAft>
-                          <a:spcPts val="0"/>
-                        </a:spcAft>
-                        <a:buClr>
-                          <a:srgbClr val="000000"/>
-                        </a:buClr>
-                        <a:buSzPts val="2400"/>
-                        <a:buFont typeface="PMingLiU"/>
-                        <a:buNone/>
-                      </a:pPr>
-                      <a:r>
-                        <a:rPr b="0" i="0" lang="en-US" sz="2400" u="none" strike="noStrike">
-                          <a:solidFill>
-                            <a:srgbClr val="000000"/>
-                          </a:solidFill>
-                          <a:latin typeface="PMingLiU"/>
-                          <a:ea typeface="PMingLiU"/>
-                          <a:cs typeface="PMingLiU"/>
-                          <a:sym typeface="PMingLiU"/>
-                        </a:rPr>
-                        <a:t>83.25%</a:t>
-                      </a:r>
-                      <a:endParaRPr b="0" i="0" sz="2400">
-                        <a:solidFill>
-                          <a:srgbClr val="000000"/>
-                        </a:solidFill>
-                        <a:latin typeface="PMingLiU"/>
-                        <a:ea typeface="PMingLiU"/>
-                        <a:cs typeface="PMingLiU"/>
-                        <a:sym typeface="PMingLiU"/>
-                      </a:endParaRPr>
-                    </a:p>
-                  </a:txBody>
-                  <a:tcPr marT="33150" marB="33150" marR="66300" marL="66300" anchor="ctr">
-                    <a:lnL cap="flat" cmpd="sng" w="9525">
-                      <a:solidFill>
-                        <a:srgbClr val="FFFFFF"/>
-                      </a:solidFill>
-                      <a:prstDash val="solid"/>
-                      <a:round/>
-                      <a:headEnd len="sm" w="sm" type="none"/>
-                      <a:tailEnd len="sm" w="sm" type="none"/>
-                    </a:lnL>
-                    <a:lnR cap="flat" cmpd="sng" w="9525">
-                      <a:solidFill>
-                        <a:srgbClr val="FFFFFF"/>
-                      </a:solidFill>
-                      <a:prstDash val="solid"/>
-                      <a:round/>
-                      <a:headEnd len="sm" w="sm" type="none"/>
-                      <a:tailEnd len="sm" w="sm" type="none"/>
-                    </a:lnR>
-                    <a:lnT cap="flat" cmpd="sng" w="9525">
-                      <a:solidFill>
-                        <a:srgbClr val="FFFFFF"/>
-                      </a:solidFill>
-                      <a:prstDash val="solid"/>
-                      <a:round/>
-                      <a:headEnd len="sm" w="sm" type="none"/>
-                      <a:tailEnd len="sm" w="sm" type="none"/>
-                    </a:lnT>
-                    <a:lnB cap="flat" cmpd="sng" w="9525">
-                      <a:solidFill>
-                        <a:srgbClr val="FFFFFF"/>
-                      </a:solidFill>
-                      <a:prstDash val="solid"/>
-                      <a:round/>
-                      <a:headEnd len="sm" w="sm" type="none"/>
-                      <a:tailEnd len="sm" w="sm" type="none"/>
-                    </a:lnB>
-                  </a:tcPr>
-                </a:tc>
-              </a:tr>
             </a:tbl>
           </a:graphicData>
         </a:graphic>
@@ -19382,7 +19042,7 @@
           <p:nvPr/>
         </p:nvGraphicFramePr>
         <p:xfrm>
-          <a:off x="700088" y="2292350"/>
+          <a:off x="700613" y="3016913"/>
           <a:ext cx="3000000" cy="3000000"/>
         </p:xfrm>
         <a:graphic>
@@ -19390,7 +19050,7 @@
             <a:tbl>
               <a:tblPr bandRow="1" firstRow="1">
                 <a:noFill/>
-                <a:tableStyleId>{C5DC600F-0F91-4E06-A19A-CB638F39DDCE}</a:tableStyleId>
+                <a:tableStyleId>{D2D53864-C1FC-41F1-9294-DA812D1AD0D8}</a:tableStyleId>
               </a:tblPr>
               <a:tblGrid>
                 <a:gridCol w="2791800"/>
@@ -19566,7 +19226,7 @@
                   </a:tcPr>
                 </a:tc>
               </a:tr>
-              <a:tr h="643750">
+              <a:tr h="919650">
                 <a:tc>
                   <a:txBody>
                     <a:bodyPr/>
@@ -19599,7 +19259,7 @@
                           <a:cs typeface="PMingLiU"/>
                           <a:sym typeface="PMingLiU"/>
                         </a:rPr>
-                        <a:t>ACC</a:t>
+                        <a:t>AUC</a:t>
                       </a:r>
                       <a:endParaRPr b="0" i="0" sz="2400">
                         <a:solidFill>
@@ -19683,7 +19343,7 @@
                           <a:cs typeface="PMingLiU"/>
                           <a:sym typeface="PMingLiU"/>
                         </a:rPr>
-                        <a:t>70.22%</a:t>
+                        <a:t>77.87%</a:t>
                       </a:r>
                       <a:endParaRPr b="0" i="0" sz="2400">
                         <a:solidFill>
@@ -19716,176 +19376,6 @@
                       <a:tailEnd len="sm" w="sm" type="none"/>
                     </a:lnR>
                     <a:lnT cap="flat" cmpd="sng" w="27600">
-                      <a:solidFill>
-                        <a:srgbClr val="FFFFFF"/>
-                      </a:solidFill>
-                      <a:prstDash val="solid"/>
-                      <a:round/>
-                      <a:headEnd len="sm" w="sm" type="none"/>
-                      <a:tailEnd len="sm" w="sm" type="none"/>
-                    </a:lnT>
-                    <a:lnB cap="flat" cmpd="sng" w="9525">
-                      <a:solidFill>
-                        <a:srgbClr val="FFFFFF"/>
-                      </a:solidFill>
-                      <a:prstDash val="solid"/>
-                      <a:round/>
-                      <a:headEnd len="sm" w="sm" type="none"/>
-                      <a:tailEnd len="sm" w="sm" type="none"/>
-                    </a:lnB>
-                  </a:tcPr>
-                </a:tc>
-              </a:tr>
-              <a:tr h="919650">
-                <a:tc>
-                  <a:txBody>
-                    <a:bodyPr/>
-                    <a:lstStyle/>
-                    <a:p>
-                      <a:pPr indent="0" lvl="0" marL="0" marR="0" rtl="0" algn="ctr">
-                        <a:lnSpc>
-                          <a:spcPct val="65625"/>
-                        </a:lnSpc>
-                        <a:spcBef>
-                          <a:spcPts val="0"/>
-                        </a:spcBef>
-                        <a:spcAft>
-                          <a:spcPts val="0"/>
-                        </a:spcAft>
-                        <a:buClr>
-                          <a:srgbClr val="000000"/>
-                        </a:buClr>
-                        <a:buSzPts val="2400"/>
-                        <a:buFont typeface="PMingLiU"/>
-                        <a:buNone/>
-                      </a:pPr>
-                      <a:r>
-                        <a:rPr b="0" i="0" lang="en-US" sz="2400" u="none" strike="noStrike">
-                          <a:solidFill>
-                            <a:srgbClr val="000000"/>
-                          </a:solidFill>
-                          <a:latin typeface="PMingLiU"/>
-                          <a:ea typeface="PMingLiU"/>
-                          <a:cs typeface="PMingLiU"/>
-                          <a:sym typeface="PMingLiU"/>
-                        </a:rPr>
-                        <a:t>AUC</a:t>
-                      </a:r>
-                      <a:endParaRPr b="0" i="0" sz="2400">
-                        <a:solidFill>
-                          <a:srgbClr val="000000"/>
-                        </a:solidFill>
-                        <a:latin typeface="PMingLiU"/>
-                        <a:ea typeface="PMingLiU"/>
-                        <a:cs typeface="PMingLiU"/>
-                        <a:sym typeface="PMingLiU"/>
-                      </a:endParaRPr>
-                    </a:p>
-                  </a:txBody>
-                  <a:tcPr marT="33150" marB="33150" marR="66300" marL="66300" anchor="ctr">
-                    <a:lnL cap="flat" cmpd="sng" w="9525">
-                      <a:solidFill>
-                        <a:srgbClr val="FFFFFF"/>
-                      </a:solidFill>
-                      <a:prstDash val="solid"/>
-                      <a:round/>
-                      <a:headEnd len="sm" w="sm" type="none"/>
-                      <a:tailEnd len="sm" w="sm" type="none"/>
-                    </a:lnL>
-                    <a:lnR cap="flat" cmpd="sng" w="9525">
-                      <a:solidFill>
-                        <a:srgbClr val="FFFFFF"/>
-                      </a:solidFill>
-                      <a:prstDash val="solid"/>
-                      <a:round/>
-                      <a:headEnd len="sm" w="sm" type="none"/>
-                      <a:tailEnd len="sm" w="sm" type="none"/>
-                    </a:lnR>
-                    <a:lnT cap="flat" cmpd="sng" w="9525">
-                      <a:solidFill>
-                        <a:srgbClr val="FFFFFF"/>
-                      </a:solidFill>
-                      <a:prstDash val="solid"/>
-                      <a:round/>
-                      <a:headEnd len="sm" w="sm" type="none"/>
-                      <a:tailEnd len="sm" w="sm" type="none"/>
-                    </a:lnT>
-                    <a:lnB cap="flat" cmpd="sng" w="9525">
-                      <a:solidFill>
-                        <a:srgbClr val="FFFFFF"/>
-                      </a:solidFill>
-                      <a:prstDash val="solid"/>
-                      <a:round/>
-                      <a:headEnd len="sm" w="sm" type="none"/>
-                      <a:tailEnd len="sm" w="sm" type="none"/>
-                    </a:lnB>
-                  </a:tcPr>
-                </a:tc>
-                <a:tc>
-                  <a:txBody>
-                    <a:bodyPr/>
-                    <a:lstStyle/>
-                    <a:p>
-                      <a:pPr indent="0" lvl="0" marL="0" marR="0" rtl="0" algn="ctr">
-                        <a:lnSpc>
-                          <a:spcPct val="65625"/>
-                        </a:lnSpc>
-                        <a:spcBef>
-                          <a:spcPts val="0"/>
-                        </a:spcBef>
-                        <a:spcAft>
-                          <a:spcPts val="0"/>
-                        </a:spcAft>
-                        <a:buClr>
-                          <a:srgbClr val="000000"/>
-                        </a:buClr>
-                        <a:buSzPts val="2400"/>
-                        <a:buFont typeface="PMingLiU"/>
-                        <a:buNone/>
-                      </a:pPr>
-                      <a:r>
-                        <a:rPr b="0" i="0" lang="en-US" sz="2400" u="none" strike="noStrike">
-                          <a:solidFill>
-                            <a:srgbClr val="000000"/>
-                          </a:solidFill>
-                          <a:latin typeface="PMingLiU"/>
-                          <a:ea typeface="PMingLiU"/>
-                          <a:cs typeface="PMingLiU"/>
-                          <a:sym typeface="PMingLiU"/>
-                        </a:rPr>
-                        <a:t>77.87%</a:t>
-                      </a:r>
-                      <a:endParaRPr b="0" i="0" sz="2400">
-                        <a:solidFill>
-                          <a:srgbClr val="000000"/>
-                        </a:solidFill>
-                        <a:latin typeface="PMingLiU"/>
-                        <a:ea typeface="PMingLiU"/>
-                        <a:cs typeface="PMingLiU"/>
-                        <a:sym typeface="PMingLiU"/>
-                      </a:endParaRPr>
-                    </a:p>
-                  </a:txBody>
-                  <a:tcPr marT="33150" marB="33150" marR="66300" marL="66300" anchor="ctr">
-                    <a:lnL cap="flat" cmpd="sng" w="9525">
-                      <a:solidFill>
-                        <a:srgbClr val="FFFFFF"/>
-                      </a:solidFill>
-                      <a:prstDash val="solid"/>
-                      <a:round/>
-                      <a:headEnd len="sm" w="sm" type="none"/>
-                      <a:tailEnd len="sm" w="sm" type="none"/>
-                    </a:lnL>
-                    <a:lnR cap="flat" cmpd="sng" w="9525">
-                      <a:solidFill>
-                        <a:srgbClr val="FFFFFF"/>
-                      </a:solidFill>
-                      <a:prstDash val="solid"/>
-                      <a:round/>
-                      <a:headEnd len="sm" w="sm" type="none"/>
-                      <a:tailEnd len="sm" w="sm" type="none"/>
-                    </a:lnR>
-                    <a:lnT cap="flat" cmpd="sng" w="9525">
                       <a:solidFill>
                         <a:srgbClr val="FFFFFF"/>
                       </a:solidFill>
@@ -20076,176 +19566,6 @@
                   </a:tcPr>
                 </a:tc>
               </a:tr>
-              <a:tr h="802650">
-                <a:tc>
-                  <a:txBody>
-                    <a:bodyPr/>
-                    <a:lstStyle/>
-                    <a:p>
-                      <a:pPr indent="0" lvl="0" marL="0" marR="0" rtl="0" algn="ctr">
-                        <a:lnSpc>
-                          <a:spcPct val="65625"/>
-                        </a:lnSpc>
-                        <a:spcBef>
-                          <a:spcPts val="0"/>
-                        </a:spcBef>
-                        <a:spcAft>
-                          <a:spcPts val="0"/>
-                        </a:spcAft>
-                        <a:buClr>
-                          <a:srgbClr val="000000"/>
-                        </a:buClr>
-                        <a:buSzPts val="2400"/>
-                        <a:buFont typeface="PMingLiU"/>
-                        <a:buNone/>
-                      </a:pPr>
-                      <a:r>
-                        <a:rPr b="0" i="0" lang="en-US" sz="2400" u="none" strike="noStrike">
-                          <a:solidFill>
-                            <a:srgbClr val="000000"/>
-                          </a:solidFill>
-                          <a:latin typeface="PMingLiU"/>
-                          <a:ea typeface="PMingLiU"/>
-                          <a:cs typeface="PMingLiU"/>
-                          <a:sym typeface="PMingLiU"/>
-                        </a:rPr>
-                        <a:t>AR</a:t>
-                      </a:r>
-                      <a:endParaRPr b="0" i="0" sz="2400">
-                        <a:solidFill>
-                          <a:srgbClr val="000000"/>
-                        </a:solidFill>
-                        <a:latin typeface="PMingLiU"/>
-                        <a:ea typeface="PMingLiU"/>
-                        <a:cs typeface="PMingLiU"/>
-                        <a:sym typeface="PMingLiU"/>
-                      </a:endParaRPr>
-                    </a:p>
-                  </a:txBody>
-                  <a:tcPr marT="33150" marB="33150" marR="66300" marL="66300" anchor="ctr">
-                    <a:lnL cap="flat" cmpd="sng" w="9525">
-                      <a:solidFill>
-                        <a:srgbClr val="FFFFFF"/>
-                      </a:solidFill>
-                      <a:prstDash val="solid"/>
-                      <a:round/>
-                      <a:headEnd len="sm" w="sm" type="none"/>
-                      <a:tailEnd len="sm" w="sm" type="none"/>
-                    </a:lnL>
-                    <a:lnR cap="flat" cmpd="sng" w="9525">
-                      <a:solidFill>
-                        <a:srgbClr val="FFFFFF"/>
-                      </a:solidFill>
-                      <a:prstDash val="solid"/>
-                      <a:round/>
-                      <a:headEnd len="sm" w="sm" type="none"/>
-                      <a:tailEnd len="sm" w="sm" type="none"/>
-                    </a:lnR>
-                    <a:lnT cap="flat" cmpd="sng" w="9525">
-                      <a:solidFill>
-                        <a:srgbClr val="FFFFFF"/>
-                      </a:solidFill>
-                      <a:prstDash val="solid"/>
-                      <a:round/>
-                      <a:headEnd len="sm" w="sm" type="none"/>
-                      <a:tailEnd len="sm" w="sm" type="none"/>
-                    </a:lnT>
-                    <a:lnB cap="flat" cmpd="sng" w="9525">
-                      <a:solidFill>
-                        <a:srgbClr val="FFFFFF"/>
-                      </a:solidFill>
-                      <a:prstDash val="solid"/>
-                      <a:round/>
-                      <a:headEnd len="sm" w="sm" type="none"/>
-                      <a:tailEnd len="sm" w="sm" type="none"/>
-                    </a:lnB>
-                  </a:tcPr>
-                </a:tc>
-                <a:tc>
-                  <a:txBody>
-                    <a:bodyPr/>
-                    <a:lstStyle/>
-                    <a:p>
-                      <a:pPr indent="0" lvl="0" marL="0" marR="0" rtl="0" algn="ctr">
-                        <a:lnSpc>
-                          <a:spcPct val="65625"/>
-                        </a:lnSpc>
-                        <a:spcBef>
-                          <a:spcPts val="0"/>
-                        </a:spcBef>
-                        <a:spcAft>
-                          <a:spcPts val="0"/>
-                        </a:spcAft>
-                        <a:buClr>
-                          <a:srgbClr val="000000"/>
-                        </a:buClr>
-                        <a:buSzPts val="2400"/>
-                        <a:buFont typeface="PMingLiU"/>
-                        <a:buNone/>
-                      </a:pPr>
-                      <a:r>
-                        <a:rPr b="0" i="0" lang="en-US" sz="2400" u="none" strike="noStrike">
-                          <a:solidFill>
-                            <a:srgbClr val="000000"/>
-                          </a:solidFill>
-                          <a:latin typeface="PMingLiU"/>
-                          <a:ea typeface="PMingLiU"/>
-                          <a:cs typeface="PMingLiU"/>
-                          <a:sym typeface="PMingLiU"/>
-                        </a:rPr>
-                        <a:t>70.03%</a:t>
-                      </a:r>
-                      <a:endParaRPr b="0" i="0" sz="2400">
-                        <a:solidFill>
-                          <a:srgbClr val="000000"/>
-                        </a:solidFill>
-                        <a:latin typeface="PMingLiU"/>
-                        <a:ea typeface="PMingLiU"/>
-                        <a:cs typeface="PMingLiU"/>
-                        <a:sym typeface="PMingLiU"/>
-                      </a:endParaRPr>
-                    </a:p>
-                  </a:txBody>
-                  <a:tcPr marT="33150" marB="33150" marR="66300" marL="66300" anchor="ctr">
-                    <a:lnL cap="flat" cmpd="sng" w="9525">
-                      <a:solidFill>
-                        <a:srgbClr val="FFFFFF"/>
-                      </a:solidFill>
-                      <a:prstDash val="solid"/>
-                      <a:round/>
-                      <a:headEnd len="sm" w="sm" type="none"/>
-                      <a:tailEnd len="sm" w="sm" type="none"/>
-                    </a:lnL>
-                    <a:lnR cap="flat" cmpd="sng" w="9525">
-                      <a:solidFill>
-                        <a:srgbClr val="FFFFFF"/>
-                      </a:solidFill>
-                      <a:prstDash val="solid"/>
-                      <a:round/>
-                      <a:headEnd len="sm" w="sm" type="none"/>
-                      <a:tailEnd len="sm" w="sm" type="none"/>
-                    </a:lnR>
-                    <a:lnT cap="flat" cmpd="sng" w="9525">
-                      <a:solidFill>
-                        <a:srgbClr val="FFFFFF"/>
-                      </a:solidFill>
-                      <a:prstDash val="solid"/>
-                      <a:round/>
-                      <a:headEnd len="sm" w="sm" type="none"/>
-                      <a:tailEnd len="sm" w="sm" type="none"/>
-                    </a:lnT>
-                    <a:lnB cap="flat" cmpd="sng" w="9525">
-                      <a:solidFill>
-                        <a:srgbClr val="FFFFFF"/>
-                      </a:solidFill>
-                      <a:prstDash val="solid"/>
-                      <a:round/>
-                      <a:headEnd len="sm" w="sm" type="none"/>
-                      <a:tailEnd len="sm" w="sm" type="none"/>
-                    </a:lnB>
-                  </a:tcPr>
-                </a:tc>
-              </a:tr>
             </a:tbl>
           </a:graphicData>
         </a:graphic>
@@ -23611,7 +22931,7 @@
             <a:tbl>
               <a:tblPr bandRow="1" firstRow="1">
                 <a:noFill/>
-                <a:tableStyleId>{C5DC600F-0F91-4E06-A19A-CB638F39DDCE}</a:tableStyleId>
+                <a:tableStyleId>{D2D53864-C1FC-41F1-9294-DA812D1AD0D8}</a:tableStyleId>
               </a:tblPr>
               <a:tblGrid>
                 <a:gridCol w="1957550"/>
@@ -25856,7 +25176,7 @@
             <a:tbl>
               <a:tblPr bandRow="1">
                 <a:noFill/>
-                <a:tableStyleId>{C5DC600F-0F91-4E06-A19A-CB638F39DDCE}</a:tableStyleId>
+                <a:tableStyleId>{D2D53864-C1FC-41F1-9294-DA812D1AD0D8}</a:tableStyleId>
               </a:tblPr>
               <a:tblGrid>
                 <a:gridCol w="2740725"/>
@@ -29408,7 +28728,7 @@
             <a:tbl>
               <a:tblPr bandRow="1" firstRow="1">
                 <a:noFill/>
-                <a:tableStyleId>{C5DC600F-0F91-4E06-A19A-CB638F39DDCE}</a:tableStyleId>
+                <a:tableStyleId>{D2D53864-C1FC-41F1-9294-DA812D1AD0D8}</a:tableStyleId>
               </a:tblPr>
               <a:tblGrid>
                 <a:gridCol w="3563925"/>
@@ -34411,7 +33731,7 @@
             <a:tbl>
               <a:tblPr bandRow="1" firstRow="1">
                 <a:noFill/>
-                <a:tableStyleId>{C5DC600F-0F91-4E06-A19A-CB638F39DDCE}</a:tableStyleId>
+                <a:tableStyleId>{D2D53864-C1FC-41F1-9294-DA812D1AD0D8}</a:tableStyleId>
               </a:tblPr>
               <a:tblGrid>
                 <a:gridCol w="3563925"/>
@@ -38928,7 +38248,7 @@
                 <a:cs typeface="PMingLiU"/>
                 <a:sym typeface="PMingLiU"/>
               </a:rPr>
-              <a:t>資料集(YOLOV10)</a:t>
+              <a:t>資料集(YOLOv10)</a:t>
             </a:r>
             <a:br>
               <a:rPr lang="en-US" sz="4800">
@@ -40157,7 +39477,7 @@
             <a:tbl>
               <a:tblPr bandRow="1" firstRow="1">
                 <a:noFill/>
-                <a:tableStyleId>{C5DC600F-0F91-4E06-A19A-CB638F39DDCE}</a:tableStyleId>
+                <a:tableStyleId>{D2D53864-C1FC-41F1-9294-DA812D1AD0D8}</a:tableStyleId>
               </a:tblPr>
               <a:tblGrid>
                 <a:gridCol w="2672950"/>

</xml_diff>